<commit_message>
add java pp t
</commit_message>
<xml_diff>
--- a/Session-01.pptx
+++ b/Session-01.pptx
@@ -263,7 +263,7 @@
             <a:fld id="{AE7A2EDF-9D4C-4951-AB5A-18C70665F772}" type="datetimeFigureOut">
               <a:rPr lang="en-US" smtClean="0"/>
               <a:pPr/>
-              <a:t>8/7/24</a:t>
+              <a:t>8/27/24</a:t>
             </a:fld>
             <a:endParaRPr lang="en-US"/>
           </a:p>
@@ -439,7 +439,7 @@
               <a:pPr>
                 <a:defRPr/>
               </a:pPr>
-              <a:t>8/7/24</a:t>
+              <a:t>8/27/24</a:t>
             </a:fld>
             <a:endParaRPr lang="en-US"/>
           </a:p>
@@ -1239,12 +1239,9 @@
             <a:pPr>
               <a:defRPr/>
             </a:pPr>
-            <a:fld id="{37B50EFD-BB46-460F-8504-1230248E0AAF}" type="datetime2">
-              <a:rPr lang="en-US" smtClean="0"/>
-              <a:pPr>
-                <a:defRPr/>
-              </a:pPr>
-              <a:t>Wednesday, August 7, 2024</a:t>
+            <a:fld id="{6D1F2392-0628-EA42-B7B7-439C03D2F184}" type="datetime2">
+              <a:rPr lang="en-IN" smtClean="0"/>
+              <a:t>Tuesday, 27 August 2024</a:t>
             </a:fld>
             <a:endParaRPr lang="en-US"/>
           </a:p>
@@ -1276,7 +1273,7 @@
             </a:pPr>
             <a:r>
               <a:rPr lang="en-US"/>
-              <a:t>KLEF                                                P-1(CTD)                                              BES-1</a:t>
+              <a:t>Dr. Naveen Kumar, Associate Professor, AIIT, AUP</a:t>
             </a:r>
           </a:p>
         </p:txBody>
@@ -1475,12 +1472,9 @@
             <a:pPr>
               <a:defRPr/>
             </a:pPr>
-            <a:fld id="{117B9AE9-D5B2-467A-9E11-5E3F32AECA1E}" type="datetime2">
-              <a:rPr lang="en-US" smtClean="0"/>
-              <a:pPr>
-                <a:defRPr/>
-              </a:pPr>
-              <a:t>Wednesday, August 7, 2024</a:t>
+            <a:fld id="{29760D74-08A1-A54F-9FD1-FD1433DDFA93}" type="datetime2">
+              <a:rPr lang="en-IN" smtClean="0"/>
+              <a:t>Tuesday, 27 August 2024</a:t>
             </a:fld>
             <a:endParaRPr lang="en-US"/>
           </a:p>
@@ -1510,7 +1504,7 @@
             </a:pPr>
             <a:r>
               <a:rPr lang="en-US"/>
-              <a:t>KLEF                                                P-1(CTD)                                              BES-1</a:t>
+              <a:t>Dr. Naveen Kumar, Associate Professor, AIIT, AUP</a:t>
             </a:r>
           </a:p>
         </p:txBody>
@@ -1678,12 +1672,9 @@
             <a:pPr>
               <a:defRPr/>
             </a:pPr>
-            <a:fld id="{575A678F-5F3E-4BB1-B5BE-6E996975CD8B}" type="datetime2">
-              <a:rPr lang="en-US" smtClean="0"/>
-              <a:pPr>
-                <a:defRPr/>
-              </a:pPr>
-              <a:t>Wednesday, August 7, 2024</a:t>
+            <a:fld id="{5E751A75-CD5B-374C-9137-EAAB1418FE6A}" type="datetime2">
+              <a:rPr lang="en-IN" smtClean="0"/>
+              <a:t>Tuesday, 27 August 2024</a:t>
             </a:fld>
             <a:endParaRPr lang="en-US"/>
           </a:p>
@@ -1713,7 +1704,7 @@
             </a:pPr>
             <a:r>
               <a:rPr lang="en-US"/>
-              <a:t>KLEF                                                P-1(CTD)                                              BES-1</a:t>
+              <a:t>Dr. Naveen Kumar, Associate Professor, AIIT, AUP</a:t>
             </a:r>
           </a:p>
         </p:txBody>
@@ -1881,12 +1872,9 @@
             <a:pPr>
               <a:defRPr/>
             </a:pPr>
-            <a:fld id="{E4F140B0-0043-464B-A0D8-C9F7FBE7330F}" type="datetime2">
-              <a:rPr lang="en-US" smtClean="0"/>
-              <a:pPr>
-                <a:defRPr/>
-              </a:pPr>
-              <a:t>Wednesday, August 7, 2024</a:t>
+            <a:fld id="{29829789-2A94-F043-9EB3-ED47244F0AF9}" type="datetime2">
+              <a:rPr lang="en-IN" smtClean="0"/>
+              <a:t>Tuesday, 27 August 2024</a:t>
             </a:fld>
             <a:endParaRPr lang="en-US"/>
           </a:p>
@@ -1916,7 +1904,7 @@
             </a:pPr>
             <a:r>
               <a:rPr lang="en-US"/>
-              <a:t>KLEF                                                P-1(CTD)                                              BES-1</a:t>
+              <a:t>Dr. Naveen Kumar, Associate Professor, AIIT, AUP</a:t>
             </a:r>
           </a:p>
         </p:txBody>
@@ -2152,12 +2140,9 @@
             <a:pPr>
               <a:defRPr/>
             </a:pPr>
-            <a:fld id="{335FA76D-FE96-4F7D-94FC-30C46E59C061}" type="datetime2">
-              <a:rPr lang="en-US" smtClean="0"/>
-              <a:pPr>
-                <a:defRPr/>
-              </a:pPr>
-              <a:t>Wednesday, August 7, 2024</a:t>
+            <a:fld id="{6779F1FA-B413-4D46-B713-665BD4F1C10E}" type="datetime2">
+              <a:rPr lang="en-IN" smtClean="0"/>
+              <a:t>Tuesday, 27 August 2024</a:t>
             </a:fld>
             <a:endParaRPr lang="en-US"/>
           </a:p>
@@ -2187,7 +2172,7 @@
             </a:pPr>
             <a:r>
               <a:rPr lang="en-US"/>
-              <a:t>KLEF                                                P-1(CTD)                                              BES-1</a:t>
+              <a:t>Dr. Naveen Kumar, Associate Professor, AIIT, AUP</a:t>
             </a:r>
           </a:p>
         </p:txBody>
@@ -2468,12 +2453,9 @@
             <a:pPr>
               <a:defRPr/>
             </a:pPr>
-            <a:fld id="{D4A19F51-1F43-47BD-A2DF-2B9F871B19DD}" type="datetime2">
-              <a:rPr lang="en-US" smtClean="0"/>
-              <a:pPr>
-                <a:defRPr/>
-              </a:pPr>
-              <a:t>Wednesday, August 7, 2024</a:t>
+            <a:fld id="{82016C62-FC2A-A542-8AE8-B50E192C67CC}" type="datetime2">
+              <a:rPr lang="en-IN" smtClean="0"/>
+              <a:t>Tuesday, 27 August 2024</a:t>
             </a:fld>
             <a:endParaRPr lang="en-US"/>
           </a:p>
@@ -2503,7 +2485,7 @@
             </a:pPr>
             <a:r>
               <a:rPr lang="en-US"/>
-              <a:t>KLEF                                                P-1(CTD)                                              BES-1</a:t>
+              <a:t>Dr. Naveen Kumar, Associate Professor, AIIT, AUP</a:t>
             </a:r>
           </a:p>
         </p:txBody>
@@ -2925,12 +2907,9 @@
             <a:pPr>
               <a:defRPr/>
             </a:pPr>
-            <a:fld id="{8BFDFC46-CF9E-43D8-8A46-8772B40BB427}" type="datetime2">
-              <a:rPr lang="en-US" smtClean="0"/>
-              <a:pPr>
-                <a:defRPr/>
-              </a:pPr>
-              <a:t>Wednesday, August 7, 2024</a:t>
+            <a:fld id="{ECA5919A-9A1F-254C-8DB8-4F23632F4EA4}" type="datetime2">
+              <a:rPr lang="en-IN" smtClean="0"/>
+              <a:t>Tuesday, 27 August 2024</a:t>
             </a:fld>
             <a:endParaRPr lang="en-US"/>
           </a:p>
@@ -2960,7 +2939,7 @@
             </a:pPr>
             <a:r>
               <a:rPr lang="en-US"/>
-              <a:t>KLEF                                                P-1(CTD)                                              BES-1</a:t>
+              <a:t>Dr. Naveen Kumar, Associate Professor, AIIT, AUP</a:t>
             </a:r>
           </a:p>
         </p:txBody>
@@ -3047,12 +3026,9 @@
             <a:pPr>
               <a:defRPr/>
             </a:pPr>
-            <a:fld id="{37B50EFD-BB46-460F-8504-1230248E0AAF}" type="datetime2">
-              <a:rPr lang="en-US" smtClean="0"/>
-              <a:pPr>
-                <a:defRPr/>
-              </a:pPr>
-              <a:t>Wednesday, August 7, 2024</a:t>
+            <a:fld id="{425AF8A7-C1F9-6F44-929E-15E5B10B3040}" type="datetime2">
+              <a:rPr lang="en-IN" smtClean="0"/>
+              <a:t>Tuesday, 27 August 2024</a:t>
             </a:fld>
             <a:endParaRPr lang="en-US"/>
           </a:p>
@@ -3084,7 +3060,7 @@
             </a:pPr>
             <a:r>
               <a:rPr lang="en-US"/>
-              <a:t>KLEF                                                P-1(CTD)                                              BES-1</a:t>
+              <a:t>Dr. Naveen Kumar, Associate Professor, AIIT, AUP</a:t>
             </a:r>
           </a:p>
         </p:txBody>
@@ -3200,12 +3176,9 @@
             <a:pPr>
               <a:defRPr/>
             </a:pPr>
-            <a:fld id="{20A3FFB0-D884-461A-89FB-3DE9446C8A2F}" type="datetime2">
-              <a:rPr lang="en-US" smtClean="0"/>
-              <a:pPr>
-                <a:defRPr/>
-              </a:pPr>
-              <a:t>Wednesday, August 7, 2024</a:t>
+            <a:fld id="{D4C583FD-29B4-CF4F-A819-63A49B905C7D}" type="datetime2">
+              <a:rPr lang="en-IN" smtClean="0"/>
+              <a:t>Tuesday, 27 August 2024</a:t>
             </a:fld>
             <a:endParaRPr lang="en-US"/>
           </a:p>
@@ -3235,7 +3208,7 @@
             </a:pPr>
             <a:r>
               <a:rPr lang="en-US"/>
-              <a:t>KLEF                                                P-1(CTD)                                              BES-1</a:t>
+              <a:t>Dr. Naveen Kumar, Associate Professor, AIIT, AUP</a:t>
             </a:r>
           </a:p>
         </p:txBody>
@@ -3505,12 +3478,9 @@
             <a:pPr>
               <a:defRPr/>
             </a:pPr>
-            <a:fld id="{CFE58E2E-6087-4536-900F-2AD9D3EA6D9D}" type="datetime2">
-              <a:rPr lang="en-US" smtClean="0"/>
-              <a:pPr>
-                <a:defRPr/>
-              </a:pPr>
-              <a:t>Wednesday, August 7, 2024</a:t>
+            <a:fld id="{F334775F-3314-4A43-BF1A-2EFE3E4381B1}" type="datetime2">
+              <a:rPr lang="en-IN" smtClean="0"/>
+              <a:t>Tuesday, 27 August 2024</a:t>
             </a:fld>
             <a:endParaRPr lang="en-US"/>
           </a:p>
@@ -3540,7 +3510,7 @@
             </a:pPr>
             <a:r>
               <a:rPr lang="en-US"/>
-              <a:t>KLEF                                                P-1(CTD)                                              BES-1</a:t>
+              <a:t>Dr. Naveen Kumar, Associate Professor, AIIT, AUP</a:t>
             </a:r>
           </a:p>
         </p:txBody>
@@ -3788,12 +3758,9 @@
             <a:pPr>
               <a:defRPr/>
             </a:pPr>
-            <a:fld id="{BA166996-E3FE-407A-8AF8-2BB59A49A8B9}" type="datetime2">
-              <a:rPr lang="en-US" smtClean="0"/>
-              <a:pPr>
-                <a:defRPr/>
-              </a:pPr>
-              <a:t>Wednesday, August 7, 2024</a:t>
+            <a:fld id="{AD351D7C-83C0-0C4F-AA47-CD42BAF11826}" type="datetime2">
+              <a:rPr lang="en-IN" smtClean="0"/>
+              <a:t>Tuesday, 27 August 2024</a:t>
             </a:fld>
             <a:endParaRPr lang="en-US"/>
           </a:p>
@@ -3823,7 +3790,7 @@
             </a:pPr>
             <a:r>
               <a:rPr lang="en-US"/>
-              <a:t>KLEF                                                P-1(CTD)                                              BES-1</a:t>
+              <a:t>Dr. Naveen Kumar, Associate Professor, AIIT, AUP</a:t>
             </a:r>
           </a:p>
         </p:txBody>
@@ -4046,12 +4013,9 @@
             <a:pPr>
               <a:defRPr/>
             </a:pPr>
-            <a:fld id="{37B50EFD-BB46-460F-8504-1230248E0AAF}" type="datetime2">
-              <a:rPr lang="en-US" smtClean="0"/>
-              <a:pPr>
-                <a:defRPr/>
-              </a:pPr>
-              <a:t>Wednesday, August 7, 2024</a:t>
+            <a:fld id="{995A914E-DEEA-7D42-BD90-11675DAF7949}" type="datetime2">
+              <a:rPr lang="en-IN" smtClean="0"/>
+              <a:t>Tuesday, 27 August 2024</a:t>
             </a:fld>
             <a:endParaRPr lang="en-US"/>
           </a:p>
@@ -4102,7 +4066,7 @@
             </a:pPr>
             <a:r>
               <a:rPr lang="en-US"/>
-              <a:t>KLEF                                                P-1(CTD)                                              BES-1</a:t>
+              <a:t>Dr. Naveen Kumar, Associate Professor, AIIT, AUP</a:t>
             </a:r>
           </a:p>
         </p:txBody>
@@ -4791,6 +4755,37 @@
           <a:effectLst/>
         </p:spPr>
       </p:pic>
+      <p:sp>
+        <p:nvSpPr>
+          <p:cNvPr id="3" name="Footer Placeholder 2">
+            <a:extLst>
+              <a:ext uri="{FF2B5EF4-FFF2-40B4-BE49-F238E27FC236}">
+                <a16:creationId xmlns:a16="http://schemas.microsoft.com/office/drawing/2014/main" id="{82AA2A12-272B-0D71-0940-70E4EBEA2860}"/>
+              </a:ext>
+            </a:extLst>
+          </p:cNvPr>
+          <p:cNvSpPr>
+            <a:spLocks noGrp="1"/>
+          </p:cNvSpPr>
+          <p:nvPr>
+            <p:ph type="ftr" sz="quarter" idx="11"/>
+          </p:nvPr>
+        </p:nvSpPr>
+        <p:spPr/>
+        <p:txBody>
+          <a:bodyPr/>
+          <a:lstStyle/>
+          <a:p>
+            <a:pPr>
+              <a:defRPr/>
+            </a:pPr>
+            <a:r>
+              <a:rPr lang="en-US"/>
+              <a:t>Dr. Naveen Kumar, Associate Professor, AIIT, AUP</a:t>
+            </a:r>
+          </a:p>
+        </p:txBody>
+      </p:sp>
     </p:spTree>
     <p:extLst>
       <p:ext uri="{BB962C8B-B14F-4D97-AF65-F5344CB8AC3E}">
@@ -5062,6 +5057,16 @@
             <a:pPr algn="l">
               <a:defRPr/>
             </a:pPr>
+            <a:r>
+              <a:rPr lang="en-US" sz="2000" b="1">
+                <a:solidFill>
+                  <a:srgbClr val="002060"/>
+                </a:solidFill>
+                <a:latin typeface="Times New Roman" pitchFamily="18" charset="0"/>
+                <a:cs typeface="Times New Roman" pitchFamily="18" charset="0"/>
+              </a:rPr>
+              <a:t>Dr. Naveen Kumar, Associate Professor, AIIT, AUP</a:t>
+            </a:r>
             <a:endParaRPr lang="en-US" sz="2000" b="1" dirty="0">
               <a:solidFill>
                 <a:srgbClr val="002060"/>
@@ -5590,6 +5595,16 @@
             <a:pPr algn="l">
               <a:defRPr/>
             </a:pPr>
+            <a:r>
+              <a:rPr lang="en-US" sz="2000" b="1">
+                <a:solidFill>
+                  <a:srgbClr val="002060"/>
+                </a:solidFill>
+                <a:latin typeface="Times New Roman" pitchFamily="18" charset="0"/>
+                <a:cs typeface="Times New Roman" pitchFamily="18" charset="0"/>
+              </a:rPr>
+              <a:t>Dr. Naveen Kumar, Associate Professor, AIIT, AUP</a:t>
+            </a:r>
             <a:endParaRPr lang="en-US" sz="2000" b="1" dirty="0">
               <a:solidFill>
                 <a:srgbClr val="002060"/>
@@ -6192,6 +6207,16 @@
             <a:pPr algn="l">
               <a:defRPr/>
             </a:pPr>
+            <a:r>
+              <a:rPr lang="en-US" sz="2000" b="1">
+                <a:solidFill>
+                  <a:srgbClr val="002060"/>
+                </a:solidFill>
+                <a:latin typeface="Times New Roman" pitchFamily="18" charset="0"/>
+                <a:cs typeface="Times New Roman" pitchFamily="18" charset="0"/>
+              </a:rPr>
+              <a:t>Dr. Naveen Kumar, Associate Professor, AIIT, AUP</a:t>
+            </a:r>
             <a:endParaRPr lang="en-US" sz="2000" b="1" dirty="0">
               <a:solidFill>
                 <a:srgbClr val="002060"/>
@@ -7989,6 +8014,16 @@
             <a:pPr algn="l">
               <a:defRPr/>
             </a:pPr>
+            <a:r>
+              <a:rPr lang="en-US" sz="2000" b="1">
+                <a:solidFill>
+                  <a:srgbClr val="002060"/>
+                </a:solidFill>
+                <a:latin typeface="Times New Roman" pitchFamily="18" charset="0"/>
+                <a:cs typeface="Times New Roman" pitchFamily="18" charset="0"/>
+              </a:rPr>
+              <a:t>Dr. Naveen Kumar, Associate Professor, AIIT, AUP</a:t>
+            </a:r>
             <a:endParaRPr lang="en-US" sz="2000" b="1" dirty="0">
               <a:solidFill>
                 <a:srgbClr val="002060"/>
@@ -8974,6 +9009,16 @@
             <a:pPr algn="l">
               <a:defRPr/>
             </a:pPr>
+            <a:r>
+              <a:rPr lang="en-US" sz="2000" b="1">
+                <a:solidFill>
+                  <a:srgbClr val="002060"/>
+                </a:solidFill>
+                <a:latin typeface="Times New Roman" pitchFamily="18" charset="0"/>
+                <a:cs typeface="Times New Roman" pitchFamily="18" charset="0"/>
+              </a:rPr>
+              <a:t>Dr. Naveen Kumar, Associate Professor, AIIT, AUP</a:t>
+            </a:r>
             <a:endParaRPr lang="en-US" sz="2000" b="1" dirty="0">
               <a:solidFill>
                 <a:srgbClr val="002060"/>
@@ -9700,6 +9745,16 @@
             <a:pPr algn="l">
               <a:defRPr/>
             </a:pPr>
+            <a:r>
+              <a:rPr lang="en-US" sz="2000" b="1">
+                <a:solidFill>
+                  <a:srgbClr val="002060"/>
+                </a:solidFill>
+                <a:latin typeface="Times New Roman" pitchFamily="18" charset="0"/>
+                <a:cs typeface="Times New Roman" pitchFamily="18" charset="0"/>
+              </a:rPr>
+              <a:t>Dr. Naveen Kumar, Associate Professor, AIIT, AUP</a:t>
+            </a:r>
             <a:endParaRPr lang="en-US" sz="2000" b="1" dirty="0">
               <a:solidFill>
                 <a:srgbClr val="002060"/>
@@ -10057,6 +10112,16 @@
             <a:pPr algn="l">
               <a:defRPr/>
             </a:pPr>
+            <a:r>
+              <a:rPr lang="en-US" sz="2000" b="1">
+                <a:solidFill>
+                  <a:srgbClr val="002060"/>
+                </a:solidFill>
+                <a:latin typeface="Times New Roman" pitchFamily="18" charset="0"/>
+                <a:cs typeface="Times New Roman" pitchFamily="18" charset="0"/>
+              </a:rPr>
+              <a:t>Dr. Naveen Kumar, Associate Professor, AIIT, AUP</a:t>
+            </a:r>
             <a:endParaRPr lang="en-US" sz="2000" b="1" dirty="0">
               <a:solidFill>
                 <a:srgbClr val="002060"/>
@@ -10428,6 +10493,16 @@
             <a:pPr algn="l">
               <a:defRPr/>
             </a:pPr>
+            <a:r>
+              <a:rPr lang="en-US" sz="2000" b="1">
+                <a:solidFill>
+                  <a:srgbClr val="002060"/>
+                </a:solidFill>
+                <a:latin typeface="Times New Roman" pitchFamily="18" charset="0"/>
+                <a:cs typeface="Times New Roman" pitchFamily="18" charset="0"/>
+              </a:rPr>
+              <a:t>Dr. Naveen Kumar, Associate Professor, AIIT, AUP</a:t>
+            </a:r>
             <a:endParaRPr lang="en-US" sz="2000" b="1" dirty="0">
               <a:solidFill>
                 <a:srgbClr val="002060"/>
@@ -10820,6 +10895,16 @@
             <a:pPr algn="l">
               <a:defRPr/>
             </a:pPr>
+            <a:r>
+              <a:rPr lang="en-US" sz="2000" b="1">
+                <a:solidFill>
+                  <a:srgbClr val="002060"/>
+                </a:solidFill>
+                <a:latin typeface="Times New Roman" pitchFamily="18" charset="0"/>
+                <a:cs typeface="Times New Roman" pitchFamily="18" charset="0"/>
+              </a:rPr>
+              <a:t>Dr. Naveen Kumar, Associate Professor, AIIT, AUP</a:t>
+            </a:r>
             <a:endParaRPr lang="en-US" sz="2000" b="1" dirty="0">
               <a:solidFill>
                 <a:srgbClr val="002060"/>
@@ -10957,6 +11042,16 @@
             <a:pPr algn="l">
               <a:defRPr/>
             </a:pPr>
+            <a:r>
+              <a:rPr lang="en-US" sz="2000" b="1">
+                <a:solidFill>
+                  <a:srgbClr val="002060"/>
+                </a:solidFill>
+                <a:latin typeface="Times New Roman" pitchFamily="18" charset="0"/>
+                <a:cs typeface="Times New Roman" pitchFamily="18" charset="0"/>
+              </a:rPr>
+              <a:t>Dr. Naveen Kumar, Associate Professor, AIIT, AUP</a:t>
+            </a:r>
             <a:endParaRPr lang="en-US" sz="2000" b="1" dirty="0">
               <a:solidFill>
                 <a:srgbClr val="002060"/>
@@ -11470,6 +11565,37 @@
                 <a:cs typeface="Times New Roman" pitchFamily="18" charset="0"/>
               </a:rPr>
               <a:t>Object Oriented Principles </a:t>
+            </a:r>
+          </a:p>
+        </p:txBody>
+      </p:sp>
+      <p:sp>
+        <p:nvSpPr>
+          <p:cNvPr id="4" name="Footer Placeholder 3">
+            <a:extLst>
+              <a:ext uri="{FF2B5EF4-FFF2-40B4-BE49-F238E27FC236}">
+                <a16:creationId xmlns:a16="http://schemas.microsoft.com/office/drawing/2014/main" id="{67BAEE59-6BC5-1F41-1B16-24FF625FFA47}"/>
+              </a:ext>
+            </a:extLst>
+          </p:cNvPr>
+          <p:cNvSpPr>
+            <a:spLocks noGrp="1"/>
+          </p:cNvSpPr>
+          <p:nvPr>
+            <p:ph type="ftr" sz="quarter" idx="11"/>
+          </p:nvPr>
+        </p:nvSpPr>
+        <p:spPr/>
+        <p:txBody>
+          <a:bodyPr/>
+          <a:lstStyle/>
+          <a:p>
+            <a:pPr>
+              <a:defRPr/>
+            </a:pPr>
+            <a:r>
+              <a:rPr lang="en-US"/>
+              <a:t>Dr. Naveen Kumar, Associate Professor, AIIT, AUP</a:t>
             </a:r>
           </a:p>
         </p:txBody>
@@ -11808,6 +11934,16 @@
             <a:pPr algn="l">
               <a:defRPr/>
             </a:pPr>
+            <a:r>
+              <a:rPr lang="en-US" sz="2000" b="1">
+                <a:solidFill>
+                  <a:srgbClr val="002060"/>
+                </a:solidFill>
+                <a:latin typeface="Times New Roman" pitchFamily="18" charset="0"/>
+                <a:cs typeface="Times New Roman" pitchFamily="18" charset="0"/>
+              </a:rPr>
+              <a:t>Dr. Naveen Kumar, Associate Professor, AIIT, AUP</a:t>
+            </a:r>
             <a:endParaRPr lang="en-US" sz="2000" b="1" dirty="0">
               <a:solidFill>
                 <a:srgbClr val="002060"/>
@@ -11959,6 +12095,16 @@
             <a:pPr algn="l">
               <a:defRPr/>
             </a:pPr>
+            <a:r>
+              <a:rPr lang="en-US" sz="2000" b="1">
+                <a:solidFill>
+                  <a:srgbClr val="002060"/>
+                </a:solidFill>
+                <a:latin typeface="Times New Roman" pitchFamily="18" charset="0"/>
+                <a:cs typeface="Times New Roman" pitchFamily="18" charset="0"/>
+              </a:rPr>
+              <a:t>Dr. Naveen Kumar, Associate Professor, AIIT, AUP</a:t>
+            </a:r>
             <a:endParaRPr lang="en-US" sz="2000" b="1" dirty="0">
               <a:solidFill>
                 <a:srgbClr val="002060"/>
@@ -12487,6 +12633,16 @@
             <a:pPr algn="l">
               <a:defRPr/>
             </a:pPr>
+            <a:r>
+              <a:rPr lang="en-US" sz="2000" b="1">
+                <a:solidFill>
+                  <a:srgbClr val="002060"/>
+                </a:solidFill>
+                <a:latin typeface="Times New Roman" pitchFamily="18" charset="0"/>
+                <a:cs typeface="Times New Roman" pitchFamily="18" charset="0"/>
+              </a:rPr>
+              <a:t>Dr. Naveen Kumar, Associate Professor, AIIT, AUP</a:t>
+            </a:r>
             <a:endParaRPr lang="en-US" sz="2000" b="1" dirty="0">
               <a:solidFill>
                 <a:srgbClr val="002060"/>
@@ -12828,6 +12984,37 @@
               </a:solidFill>
               <a:cs typeface="Arial"/>
             </a:endParaRPr>
+          </a:p>
+        </p:txBody>
+      </p:sp>
+      <p:sp>
+        <p:nvSpPr>
+          <p:cNvPr id="4" name="Footer Placeholder 3">
+            <a:extLst>
+              <a:ext uri="{FF2B5EF4-FFF2-40B4-BE49-F238E27FC236}">
+                <a16:creationId xmlns:a16="http://schemas.microsoft.com/office/drawing/2014/main" id="{62D5942E-0554-9724-AA5A-8A529057ED54}"/>
+              </a:ext>
+            </a:extLst>
+          </p:cNvPr>
+          <p:cNvSpPr>
+            <a:spLocks noGrp="1"/>
+          </p:cNvSpPr>
+          <p:nvPr>
+            <p:ph type="ftr" sz="quarter" idx="11"/>
+          </p:nvPr>
+        </p:nvSpPr>
+        <p:spPr/>
+        <p:txBody>
+          <a:bodyPr/>
+          <a:lstStyle/>
+          <a:p>
+            <a:pPr>
+              <a:defRPr/>
+            </a:pPr>
+            <a:r>
+              <a:rPr lang="en-US"/>
+              <a:t>Dr. Naveen Kumar, Associate Professor, AIIT, AUP</a:t>
+            </a:r>
           </a:p>
         </p:txBody>
       </p:sp>
@@ -13256,6 +13443,37 @@
           <a:effectLst/>
         </p:spPr>
       </p:pic>
+      <p:sp>
+        <p:nvSpPr>
+          <p:cNvPr id="4" name="Footer Placeholder 3">
+            <a:extLst>
+              <a:ext uri="{FF2B5EF4-FFF2-40B4-BE49-F238E27FC236}">
+                <a16:creationId xmlns:a16="http://schemas.microsoft.com/office/drawing/2014/main" id="{07A0A59D-8F40-A035-CDE9-9D3FEA76AA62}"/>
+              </a:ext>
+            </a:extLst>
+          </p:cNvPr>
+          <p:cNvSpPr>
+            <a:spLocks noGrp="1"/>
+          </p:cNvSpPr>
+          <p:nvPr>
+            <p:ph type="ftr" sz="quarter" idx="11"/>
+          </p:nvPr>
+        </p:nvSpPr>
+        <p:spPr/>
+        <p:txBody>
+          <a:bodyPr/>
+          <a:lstStyle/>
+          <a:p>
+            <a:pPr>
+              <a:defRPr/>
+            </a:pPr>
+            <a:r>
+              <a:rPr lang="en-US"/>
+              <a:t>Dr. Naveen Kumar, Associate Professor, AIIT, AUP</a:t>
+            </a:r>
+          </a:p>
+        </p:txBody>
+      </p:sp>
     </p:spTree>
     <p:extLst>
       <p:ext uri="{BB962C8B-B14F-4D97-AF65-F5344CB8AC3E}">
@@ -13687,6 +13905,37 @@
           </a:p>
         </p:txBody>
       </p:sp>
+      <p:sp>
+        <p:nvSpPr>
+          <p:cNvPr id="3" name="Footer Placeholder 2">
+            <a:extLst>
+              <a:ext uri="{FF2B5EF4-FFF2-40B4-BE49-F238E27FC236}">
+                <a16:creationId xmlns:a16="http://schemas.microsoft.com/office/drawing/2014/main" id="{3D4BB8D4-E7EB-03EE-40F1-D2A17B53ED30}"/>
+              </a:ext>
+            </a:extLst>
+          </p:cNvPr>
+          <p:cNvSpPr>
+            <a:spLocks noGrp="1"/>
+          </p:cNvSpPr>
+          <p:nvPr>
+            <p:ph type="ftr" sz="quarter" idx="11"/>
+          </p:nvPr>
+        </p:nvSpPr>
+        <p:spPr/>
+        <p:txBody>
+          <a:bodyPr/>
+          <a:lstStyle/>
+          <a:p>
+            <a:pPr>
+              <a:defRPr/>
+            </a:pPr>
+            <a:r>
+              <a:rPr lang="en-US"/>
+              <a:t>Dr. Naveen Kumar, Associate Professor, AIIT, AUP</a:t>
+            </a:r>
+          </a:p>
+        </p:txBody>
+      </p:sp>
     </p:spTree>
   </p:cSld>
   <p:clrMapOvr>
@@ -14285,6 +14534,37 @@
           <a:effectLst/>
         </p:spPr>
       </p:pic>
+      <p:sp>
+        <p:nvSpPr>
+          <p:cNvPr id="4" name="Footer Placeholder 3">
+            <a:extLst>
+              <a:ext uri="{FF2B5EF4-FFF2-40B4-BE49-F238E27FC236}">
+                <a16:creationId xmlns:a16="http://schemas.microsoft.com/office/drawing/2014/main" id="{F21B06C9-870A-8350-2253-ECAF26CC279E}"/>
+              </a:ext>
+            </a:extLst>
+          </p:cNvPr>
+          <p:cNvSpPr>
+            <a:spLocks noGrp="1"/>
+          </p:cNvSpPr>
+          <p:nvPr>
+            <p:ph type="ftr" sz="quarter" idx="11"/>
+          </p:nvPr>
+        </p:nvSpPr>
+        <p:spPr/>
+        <p:txBody>
+          <a:bodyPr/>
+          <a:lstStyle/>
+          <a:p>
+            <a:pPr>
+              <a:defRPr/>
+            </a:pPr>
+            <a:r>
+              <a:rPr lang="en-US"/>
+              <a:t>Dr. Naveen Kumar, Associate Professor, AIIT, AUP</a:t>
+            </a:r>
+          </a:p>
+        </p:txBody>
+      </p:sp>
     </p:spTree>
   </p:cSld>
   <p:clrMapOvr>
@@ -14601,6 +14881,37 @@
           <a:effectLst/>
         </p:spPr>
       </p:pic>
+      <p:sp>
+        <p:nvSpPr>
+          <p:cNvPr id="2" name="Footer Placeholder 1">
+            <a:extLst>
+              <a:ext uri="{FF2B5EF4-FFF2-40B4-BE49-F238E27FC236}">
+                <a16:creationId xmlns:a16="http://schemas.microsoft.com/office/drawing/2014/main" id="{AEA6E65F-DABD-7BBC-C17F-F5C48107F597}"/>
+              </a:ext>
+            </a:extLst>
+          </p:cNvPr>
+          <p:cNvSpPr>
+            <a:spLocks noGrp="1"/>
+          </p:cNvSpPr>
+          <p:nvPr>
+            <p:ph type="ftr" sz="quarter" idx="11"/>
+          </p:nvPr>
+        </p:nvSpPr>
+        <p:spPr/>
+        <p:txBody>
+          <a:bodyPr/>
+          <a:lstStyle/>
+          <a:p>
+            <a:pPr>
+              <a:defRPr/>
+            </a:pPr>
+            <a:r>
+              <a:rPr lang="en-US"/>
+              <a:t>Dr. Naveen Kumar, Associate Professor, AIIT, AUP</a:t>
+            </a:r>
+          </a:p>
+        </p:txBody>
+      </p:sp>
     </p:spTree>
   </p:cSld>
   <p:clrMapOvr>
@@ -14936,6 +15247,16 @@
             <a:pPr algn="l">
               <a:defRPr/>
             </a:pPr>
+            <a:r>
+              <a:rPr lang="en-US" sz="2000" b="1">
+                <a:solidFill>
+                  <a:srgbClr val="002060"/>
+                </a:solidFill>
+                <a:latin typeface="Times New Roman" pitchFamily="18" charset="0"/>
+                <a:cs typeface="Times New Roman" pitchFamily="18" charset="0"/>
+              </a:rPr>
+              <a:t>Dr. Naveen Kumar, Associate Professor, AIIT, AUP</a:t>
+            </a:r>
             <a:endParaRPr lang="en-US" sz="2000" b="1" dirty="0">
               <a:solidFill>
                 <a:srgbClr val="002060"/>
@@ -15654,6 +15975,16 @@
             <a:pPr algn="l">
               <a:defRPr/>
             </a:pPr>
+            <a:r>
+              <a:rPr lang="en-US" sz="2000" b="1">
+                <a:solidFill>
+                  <a:srgbClr val="002060"/>
+                </a:solidFill>
+                <a:latin typeface="Times New Roman" pitchFamily="18" charset="0"/>
+                <a:cs typeface="Times New Roman" pitchFamily="18" charset="0"/>
+              </a:rPr>
+              <a:t>Dr. Naveen Kumar, Associate Professor, AIIT, AUP</a:t>
+            </a:r>
             <a:endParaRPr lang="en-US" sz="2000" b="1" dirty="0">
               <a:solidFill>
                 <a:srgbClr val="002060"/>

</xml_diff>